<commit_message>
Add OpenCV red-mask detection photo to Alexis's slides; rebuild deck
</commit_message>
<xml_diff>
--- a/Weekly Reports/Self-Driving-RC-Car.pptx
+++ b/Weekly Reports/Self-Driving-RC-Car.pptx
@@ -18,6 +18,7 @@
     <p:sldId id="266" r:id="rId16"/>
     <p:sldId id="267" r:id="rId17"/>
     <p:sldId id="268" r:id="rId18"/>
+    <p:sldId id="269" r:id="rId19"/>
   </p:sldIdLst>
   <p:sldSz cx="12192000" cy="6858000"/>
   <p:notesSz cx="6858000" cy="9144000"/>
@@ -3457,6 +3458,658 @@
                 <a:ea typeface="Aptos Display"/>
                 <a:cs typeface="Aptos Display"/>
               </a:rPr>
+              <a:t>ROS 2 could split our pipeline into eight nodes</a:t>
+            </a:r>
+          </a:p>
+        </p:txBody>
+      </p:sp>
+      <p:sp>
+        <p:nvSpPr>
+          <p:cNvPr id="3" name="Subtitle"/>
+          <p:cNvSpPr txBox="1"/>
+          <p:nvPr/>
+        </p:nvSpPr>
+        <p:spPr>
+          <a:xfrm>
+            <a:off x="786384" y="1024128"/>
+            <a:ext cx="10607040" cy="365760"/>
+          </a:xfrm>
+          <a:prstGeom prst="rect">
+            <a:avLst/>
+          </a:prstGeom>
+          <a:noFill/>
+        </p:spPr>
+        <p:txBody>
+          <a:bodyPr wrap="square" lIns="0" tIns="0" rIns="0" bIns="0" anchor="t">
+            <a:noAutofit/>
+          </a:bodyPr>
+          <a:lstStyle/>
+          <a:p>
+            <a:pPr marL="0" indent="0" algn="l">
+              <a:spcBef>
+                <a:spcPts val="0"/>
+              </a:spcBef>
+              <a:buNone/>
+            </a:pPr>
+            <a:r>
+              <a:rPr lang="en-US" sz="1500" b="1" dirty="0">
+                <a:solidFill>
+                  <a:srgbClr val="000000"/>
+                </a:solidFill>
+                <a:latin typeface="Aptos"/>
+                <a:ea typeface="Aptos"/>
+                <a:cs typeface="Aptos"/>
+              </a:rPr>
+              <a:t>Preliminary node structure for the car; each node does one job</a:t>
+            </a:r>
+          </a:p>
+        </p:txBody>
+      </p:sp>
+      <p:sp>
+        <p:nvSpPr>
+          <p:cNvPr id="4" name="Nodes"/>
+          <p:cNvSpPr txBox="1"/>
+          <p:nvPr/>
+        </p:nvSpPr>
+        <p:spPr>
+          <a:xfrm>
+            <a:off x="786384" y="1719072"/>
+            <a:ext cx="6309360" cy="384048"/>
+          </a:xfrm>
+          <a:prstGeom prst="rect">
+            <a:avLst/>
+          </a:prstGeom>
+          <a:noFill/>
+        </p:spPr>
+        <p:txBody>
+          <a:bodyPr wrap="square" lIns="0" tIns="0" rIns="0" bIns="0" anchor="t">
+            <a:noAutofit/>
+          </a:bodyPr>
+          <a:lstStyle/>
+          <a:p>
+            <a:pPr marL="0" indent="0" algn="l">
+              <a:spcBef>
+                <a:spcPts val="0"/>
+              </a:spcBef>
+              <a:buNone/>
+            </a:pPr>
+            <a:r>
+              <a:rPr lang="en-US" sz="1950" b="1" dirty="0">
+                <a:solidFill>
+                  <a:srgbClr val="30669D"/>
+                </a:solidFill>
+                <a:latin typeface="Aptos"/>
+                <a:ea typeface="Aptos"/>
+                <a:cs typeface="Aptos"/>
+              </a:rPr>
+              <a:t>Nodes</a:t>
+            </a:r>
+          </a:p>
+        </p:txBody>
+      </p:sp>
+      <p:sp>
+        <p:nvSpPr>
+          <p:cNvPr id="5" name="Node list"/>
+          <p:cNvSpPr txBox="1"/>
+          <p:nvPr/>
+        </p:nvSpPr>
+        <p:spPr>
+          <a:xfrm>
+            <a:off x="786384" y="2240280"/>
+            <a:ext cx="6309360" cy="4023360"/>
+          </a:xfrm>
+          <a:prstGeom prst="rect">
+            <a:avLst/>
+          </a:prstGeom>
+          <a:noFill/>
+        </p:spPr>
+        <p:txBody>
+          <a:bodyPr wrap="square" lIns="0" tIns="0" rIns="0" bIns="0" anchor="t">
+            <a:noAutofit/>
+          </a:bodyPr>
+          <a:lstStyle/>
+          <a:p>
+            <a:pPr marL="228600" indent="-228600" algn="l">
+              <a:spcBef>
+                <a:spcPts val="0"/>
+              </a:spcBef>
+              <a:buClr>
+                <a:srgbClr val="30669D"/>
+              </a:buClr>
+              <a:buFont typeface="Arial"/>
+              <a:buChar char="•"/>
+            </a:pPr>
+            <a:r>
+              <a:rPr lang="en-US" sz="1600" b="1" dirty="0">
+                <a:solidFill>
+                  <a:srgbClr val="000000"/>
+                </a:solidFill>
+                <a:latin typeface="Aptos"/>
+                <a:ea typeface="Aptos"/>
+                <a:cs typeface="Aptos"/>
+              </a:rPr>
+              <a:t>Camera: </a:t>
+            </a:r>
+            <a:r>
+              <a:rPr lang="en-US" sz="1600" b="0" dirty="0">
+                <a:solidFill>
+                  <a:srgbClr val="000000"/>
+                </a:solidFill>
+                <a:latin typeface="Aptos"/>
+                <a:ea typeface="Aptos"/>
+                <a:cs typeface="Aptos"/>
+              </a:rPr>
+              <a:t>streams video from the Pi Camera Module 3</a:t>
+            </a:r>
+          </a:p>
+          <a:p>
+            <a:pPr marL="228600" indent="-228600" algn="l">
+              <a:spcBef>
+                <a:spcPts val="700"/>
+              </a:spcBef>
+              <a:buClr>
+                <a:srgbClr val="30669D"/>
+              </a:buClr>
+              <a:buFont typeface="Arial"/>
+              <a:buChar char="•"/>
+            </a:pPr>
+            <a:r>
+              <a:rPr lang="en-US" sz="1600" b="1" dirty="0">
+                <a:solidFill>
+                  <a:srgbClr val="000000"/>
+                </a:solidFill>
+                <a:latin typeface="Aptos"/>
+                <a:ea typeface="Aptos"/>
+                <a:cs typeface="Aptos"/>
+              </a:rPr>
+              <a:t>Sign detector: </a:t>
+            </a:r>
+            <a:r>
+              <a:rPr lang="en-US" sz="1600" b="0" dirty="0">
+                <a:solidFill>
+                  <a:srgbClr val="000000"/>
+                </a:solidFill>
+                <a:latin typeface="Aptos"/>
+                <a:ea typeface="Aptos"/>
+                <a:cs typeface="Aptos"/>
+              </a:rPr>
+              <a:t>runs the vision model and reports each sign’s type, confidence and position</a:t>
+            </a:r>
+          </a:p>
+          <a:p>
+            <a:pPr marL="228600" indent="-228600" algn="l">
+              <a:spcBef>
+                <a:spcPts val="700"/>
+              </a:spcBef>
+              <a:buClr>
+                <a:srgbClr val="30669D"/>
+              </a:buClr>
+              <a:buFont typeface="Arial"/>
+              <a:buChar char="•"/>
+            </a:pPr>
+            <a:r>
+              <a:rPr lang="en-US" sz="1600" b="1" dirty="0">
+                <a:solidFill>
+                  <a:srgbClr val="000000"/>
+                </a:solidFill>
+                <a:latin typeface="Aptos"/>
+                <a:ea typeface="Aptos"/>
+                <a:cs typeface="Aptos"/>
+              </a:rPr>
+              <a:t>Line sensor: </a:t>
+            </a:r>
+            <a:r>
+              <a:rPr lang="en-US" sz="1600" b="0" dirty="0">
+                <a:solidFill>
+                  <a:srgbClr val="000000"/>
+                </a:solidFill>
+                <a:latin typeface="Aptos"/>
+                <a:ea typeface="Aptos"/>
+                <a:cs typeface="Aptos"/>
+              </a:rPr>
+              <a:t>tracks the lane lines with TCRT5000 IR sensors</a:t>
+            </a:r>
+          </a:p>
+          <a:p>
+            <a:pPr marL="228600" indent="-228600" algn="l">
+              <a:spcBef>
+                <a:spcPts val="700"/>
+              </a:spcBef>
+              <a:buClr>
+                <a:srgbClr val="30669D"/>
+              </a:buClr>
+              <a:buFont typeface="Arial"/>
+              <a:buChar char="•"/>
+            </a:pPr>
+            <a:r>
+              <a:rPr lang="en-US" sz="1600" b="1" dirty="0">
+                <a:solidFill>
+                  <a:srgbClr val="000000"/>
+                </a:solidFill>
+                <a:latin typeface="Aptos"/>
+                <a:ea typeface="Aptos"/>
+                <a:cs typeface="Aptos"/>
+              </a:rPr>
+              <a:t>IMU: </a:t>
+            </a:r>
+            <a:r>
+              <a:rPr lang="en-US" sz="1600" b="0" dirty="0">
+                <a:solidFill>
+                  <a:srgbClr val="000000"/>
+                </a:solidFill>
+                <a:latin typeface="Aptos"/>
+                <a:ea typeface="Aptos"/>
+                <a:cs typeface="Aptos"/>
+              </a:rPr>
+              <a:t>reports turning and motion; detects if the car is stuck</a:t>
+            </a:r>
+          </a:p>
+          <a:p>
+            <a:pPr marL="228600" indent="-228600" algn="l">
+              <a:spcBef>
+                <a:spcPts val="700"/>
+              </a:spcBef>
+              <a:buClr>
+                <a:srgbClr val="30669D"/>
+              </a:buClr>
+              <a:buFont typeface="Arial"/>
+              <a:buChar char="•"/>
+            </a:pPr>
+            <a:r>
+              <a:rPr lang="en-US" sz="1600" b="1" dirty="0">
+                <a:solidFill>
+                  <a:srgbClr val="000000"/>
+                </a:solidFill>
+                <a:latin typeface="Aptos"/>
+                <a:ea typeface="Aptos"/>
+                <a:cs typeface="Aptos"/>
+              </a:rPr>
+              <a:t>Behavior: </a:t>
+            </a:r>
+            <a:r>
+              <a:rPr lang="en-US" sz="1600" b="0" dirty="0">
+                <a:solidFill>
+                  <a:srgbClr val="000000"/>
+                </a:solidFill>
+                <a:latin typeface="Aptos"/>
+                <a:ea typeface="Aptos"/>
+                <a:cs typeface="Aptos"/>
+              </a:rPr>
+              <a:t>a state machine that turns signs, lane position and IMU data into driving decisions</a:t>
+            </a:r>
+          </a:p>
+          <a:p>
+            <a:pPr marL="228600" indent="-228600" algn="l">
+              <a:spcBef>
+                <a:spcPts val="700"/>
+              </a:spcBef>
+              <a:buClr>
+                <a:srgbClr val="30669D"/>
+              </a:buClr>
+              <a:buFont typeface="Arial"/>
+              <a:buChar char="•"/>
+            </a:pPr>
+            <a:r>
+              <a:rPr lang="en-US" sz="1600" b="1" dirty="0">
+                <a:solidFill>
+                  <a:srgbClr val="000000"/>
+                </a:solidFill>
+                <a:latin typeface="Aptos"/>
+                <a:ea typeface="Aptos"/>
+                <a:cs typeface="Aptos"/>
+              </a:rPr>
+              <a:t>Motor driver: </a:t>
+            </a:r>
+            <a:r>
+              <a:rPr lang="en-US" sz="1600" b="0" dirty="0">
+                <a:solidFill>
+                  <a:srgbClr val="000000"/>
+                </a:solidFill>
+                <a:latin typeface="Aptos"/>
+                <a:ea typeface="Aptos"/>
+                <a:cs typeface="Aptos"/>
+              </a:rPr>
+              <a:t>drives the wheels through the Waveshare HAT and stops if commands stop arriving</a:t>
+            </a:r>
+          </a:p>
+          <a:p>
+            <a:pPr marL="228600" indent="-228600" algn="l">
+              <a:spcBef>
+                <a:spcPts val="700"/>
+              </a:spcBef>
+              <a:buClr>
+                <a:srgbClr val="30669D"/>
+              </a:buClr>
+              <a:buFont typeface="Arial"/>
+              <a:buChar char="•"/>
+            </a:pPr>
+            <a:r>
+              <a:rPr lang="en-US" sz="1600" b="1" dirty="0">
+                <a:solidFill>
+                  <a:srgbClr val="000000"/>
+                </a:solidFill>
+                <a:latin typeface="Aptos"/>
+                <a:ea typeface="Aptos"/>
+                <a:cs typeface="Aptos"/>
+              </a:rPr>
+              <a:t>LCD: </a:t>
+            </a:r>
+            <a:r>
+              <a:rPr lang="en-US" sz="1600" b="0" dirty="0">
+                <a:solidFill>
+                  <a:srgbClr val="000000"/>
+                </a:solidFill>
+                <a:latin typeface="Aptos"/>
+                <a:ea typeface="Aptos"/>
+                <a:cs typeface="Aptos"/>
+              </a:rPr>
+              <a:t>shows the car’s state and the last sign detected</a:t>
+            </a:r>
+          </a:p>
+          <a:p>
+            <a:pPr marL="228600" indent="-228600" algn="l">
+              <a:spcBef>
+                <a:spcPts val="700"/>
+              </a:spcBef>
+              <a:buClr>
+                <a:srgbClr val="30669D"/>
+              </a:buClr>
+              <a:buFont typeface="Arial"/>
+              <a:buChar char="•"/>
+            </a:pPr>
+            <a:r>
+              <a:rPr lang="en-US" sz="1600" b="1" dirty="0">
+                <a:solidFill>
+                  <a:srgbClr val="000000"/>
+                </a:solidFill>
+                <a:latin typeface="Aptos"/>
+                <a:ea typeface="Aptos"/>
+                <a:cs typeface="Aptos"/>
+              </a:rPr>
+              <a:t>Teleop: </a:t>
+            </a:r>
+            <a:r>
+              <a:rPr lang="en-US" sz="1600" b="0" dirty="0">
+                <a:solidFill>
+                  <a:srgbClr val="000000"/>
+                </a:solidFill>
+                <a:latin typeface="Aptos"/>
+                <a:ea typeface="Aptos"/>
+                <a:cs typeface="Aptos"/>
+              </a:rPr>
+              <a:t>lets a person take over and drive manually</a:t>
+            </a:r>
+          </a:p>
+        </p:txBody>
+      </p:sp>
+      <p:sp>
+        <p:nvSpPr>
+          <p:cNvPr id="6" name="Why ROS 2"/>
+          <p:cNvSpPr txBox="1"/>
+          <p:nvPr/>
+        </p:nvSpPr>
+        <p:spPr>
+          <a:xfrm>
+            <a:off x="7635240" y="1719072"/>
+            <a:ext cx="3794760" cy="384048"/>
+          </a:xfrm>
+          <a:prstGeom prst="rect">
+            <a:avLst/>
+          </a:prstGeom>
+          <a:noFill/>
+        </p:spPr>
+        <p:txBody>
+          <a:bodyPr wrap="square" lIns="0" tIns="0" rIns="0" bIns="0" anchor="t">
+            <a:noAutofit/>
+          </a:bodyPr>
+          <a:lstStyle/>
+          <a:p>
+            <a:pPr marL="0" indent="0" algn="l">
+              <a:spcBef>
+                <a:spcPts val="0"/>
+              </a:spcBef>
+              <a:buNone/>
+            </a:pPr>
+            <a:r>
+              <a:rPr lang="en-US" sz="1950" b="1" dirty="0">
+                <a:solidFill>
+                  <a:srgbClr val="30669D"/>
+                </a:solidFill>
+                <a:latin typeface="Aptos"/>
+                <a:ea typeface="Aptos"/>
+                <a:cs typeface="Aptos"/>
+              </a:rPr>
+              <a:t>Why ROS 2</a:t>
+            </a:r>
+          </a:p>
+        </p:txBody>
+      </p:sp>
+      <p:sp>
+        <p:nvSpPr>
+          <p:cNvPr id="7" name="Why ROS 2 list"/>
+          <p:cNvSpPr txBox="1"/>
+          <p:nvPr/>
+        </p:nvSpPr>
+        <p:spPr>
+          <a:xfrm>
+            <a:off x="7635240" y="2240280"/>
+            <a:ext cx="3794760" cy="2103120"/>
+          </a:xfrm>
+          <a:prstGeom prst="rect">
+            <a:avLst/>
+          </a:prstGeom>
+          <a:noFill/>
+        </p:spPr>
+        <p:txBody>
+          <a:bodyPr wrap="square" lIns="0" tIns="0" rIns="0" bIns="0" anchor="t">
+            <a:noAutofit/>
+          </a:bodyPr>
+          <a:lstStyle/>
+          <a:p>
+            <a:pPr marL="228600" indent="-228600" algn="l">
+              <a:spcBef>
+                <a:spcPts val="0"/>
+              </a:spcBef>
+              <a:buClr>
+                <a:srgbClr val="30669D"/>
+              </a:buClr>
+              <a:buFont typeface="Arial"/>
+              <a:buChar char="•"/>
+            </a:pPr>
+            <a:r>
+              <a:rPr lang="en-US" sz="1600" b="0" dirty="0">
+                <a:solidFill>
+                  <a:srgbClr val="000000"/>
+                </a:solidFill>
+                <a:latin typeface="Aptos"/>
+                <a:ea typeface="Aptos"/>
+                <a:cs typeface="Aptos"/>
+              </a:rPr>
+              <a:t>Each teammate can own a node without touching the others</a:t>
+            </a:r>
+          </a:p>
+          <a:p>
+            <a:pPr marL="228600" indent="-228600" algn="l">
+              <a:spcBef>
+                <a:spcPts val="900"/>
+              </a:spcBef>
+              <a:buClr>
+                <a:srgbClr val="30669D"/>
+              </a:buClr>
+              <a:buFont typeface="Arial"/>
+              <a:buChar char="•"/>
+            </a:pPr>
+            <a:r>
+              <a:rPr lang="en-US" sz="1600" b="0" dirty="0">
+                <a:solidFill>
+                  <a:srgbClr val="000000"/>
+                </a:solidFill>
+                <a:latin typeface="Aptos"/>
+                <a:ea typeface="Aptos"/>
+                <a:cs typeface="Aptos"/>
+              </a:rPr>
+              <a:t>Recorded drives can be replayed to test without the car</a:t>
+            </a:r>
+          </a:p>
+          <a:p>
+            <a:pPr marL="228600" indent="-228600" algn="l">
+              <a:spcBef>
+                <a:spcPts val="900"/>
+              </a:spcBef>
+              <a:buClr>
+                <a:srgbClr val="30669D"/>
+              </a:buClr>
+              <a:buFont typeface="Arial"/>
+              <a:buChar char="•"/>
+            </a:pPr>
+            <a:r>
+              <a:rPr lang="en-US" sz="1600" b="0" dirty="0">
+                <a:solidFill>
+                  <a:srgbClr val="000000"/>
+                </a:solidFill>
+                <a:latin typeface="Aptos"/>
+                <a:ea typeface="Aptos"/>
+                <a:cs typeface="Aptos"/>
+              </a:rPr>
+              <a:t>Laptops can watch the camera feed and topics live</a:t>
+            </a:r>
+          </a:p>
+        </p:txBody>
+      </p:sp>
+      <p:sp>
+        <p:nvSpPr>
+          <p:cNvPr id="8" name="Trade-off"/>
+          <p:cNvSpPr txBox="1"/>
+          <p:nvPr/>
+        </p:nvSpPr>
+        <p:spPr>
+          <a:xfrm>
+            <a:off x="7635240" y="4434840"/>
+            <a:ext cx="3794760" cy="384048"/>
+          </a:xfrm>
+          <a:prstGeom prst="rect">
+            <a:avLst/>
+          </a:prstGeom>
+          <a:noFill/>
+        </p:spPr>
+        <p:txBody>
+          <a:bodyPr wrap="square" lIns="0" tIns="0" rIns="0" bIns="0" anchor="t">
+            <a:noAutofit/>
+          </a:bodyPr>
+          <a:lstStyle/>
+          <a:p>
+            <a:pPr marL="0" indent="0" algn="l">
+              <a:spcBef>
+                <a:spcPts val="0"/>
+              </a:spcBef>
+              <a:buNone/>
+            </a:pPr>
+            <a:r>
+              <a:rPr lang="en-US" sz="1950" b="1" dirty="0">
+                <a:solidFill>
+                  <a:srgbClr val="30669D"/>
+                </a:solidFill>
+                <a:latin typeface="Aptos"/>
+                <a:ea typeface="Aptos"/>
+                <a:cs typeface="Aptos"/>
+              </a:rPr>
+              <a:t>Trade-off</a:t>
+            </a:r>
+          </a:p>
+        </p:txBody>
+      </p:sp>
+      <p:sp>
+        <p:nvSpPr>
+          <p:cNvPr id="9" name="Trade-off text"/>
+          <p:cNvSpPr txBox="1"/>
+          <p:nvPr/>
+        </p:nvSpPr>
+        <p:spPr>
+          <a:xfrm>
+            <a:off x="7635240" y="4956048"/>
+            <a:ext cx="3794760" cy="1280160"/>
+          </a:xfrm>
+          <a:prstGeom prst="rect">
+            <a:avLst/>
+          </a:prstGeom>
+          <a:noFill/>
+        </p:spPr>
+        <p:txBody>
+          <a:bodyPr wrap="square" lIns="0" tIns="0" rIns="0" bIns="0" anchor="t">
+            <a:noAutofit/>
+          </a:bodyPr>
+          <a:lstStyle/>
+          <a:p>
+            <a:pPr marL="0" indent="0" algn="l">
+              <a:spcBef>
+                <a:spcPts val="0"/>
+              </a:spcBef>
+              <a:buNone/>
+            </a:pPr>
+            <a:r>
+              <a:rPr lang="en-US" sz="1600" b="0" dirty="0">
+                <a:solidFill>
+                  <a:srgbClr val="000000"/>
+                </a:solidFill>
+                <a:latin typeface="Aptos"/>
+                <a:ea typeface="Aptos"/>
+                <a:cs typeface="Aptos"/>
+              </a:rPr>
+              <a:t>More upfront setup than a single script, including a custom Docker build for the CM5 camera</a:t>
+            </a:r>
+          </a:p>
+        </p:txBody>
+      </p:sp>
+    </p:spTree>
+  </p:cSld>
+  <p:clrMapOvr>
+    <a:masterClrMapping/>
+  </p:clrMapOvr>
+</p:sld>
+</file>
+
+<file path=ppt/slides/slide11.xml><?xml version="1.0" encoding="utf-8"?>
+<p:sld xmlns:a="http://schemas.openxmlformats.org/drawingml/2006/main" xmlns:p="http://schemas.openxmlformats.org/presentationml/2006/main" xmlns:r="http://schemas.openxmlformats.org/officeDocument/2006/relationships">
+  <p:cSld>
+    <p:spTree>
+      <p:nvGrpSpPr>
+        <p:cNvPr id="1" name=""/>
+        <p:cNvGrpSpPr/>
+        <p:nvPr/>
+      </p:nvGrpSpPr>
+      <p:grpSpPr/>
+      <p:sp>
+        <p:nvSpPr>
+          <p:cNvPr id="2" name="Title"/>
+          <p:cNvSpPr>
+            <a:spLocks noGrp="1"/>
+          </p:cNvSpPr>
+          <p:nvPr>
+            <p:ph type="title"/>
+          </p:nvPr>
+        </p:nvSpPr>
+        <p:spPr>
+          <a:xfrm>
+            <a:off x="768096" y="365760"/>
+            <a:ext cx="10789920" cy="658368"/>
+          </a:xfrm>
+        </p:spPr>
+        <p:txBody>
+          <a:bodyPr lIns="0" tIns="0" rIns="0" bIns="0" anchor="b">
+            <a:normAutofit/>
+          </a:bodyPr>
+          <a:lstStyle/>
+          <a:p>
+            <a:pPr algn="l"/>
+            <a:r>
+              <a:rPr lang="en-US" sz="3500" b="0" dirty="0">
+                <a:solidFill>
+                  <a:srgbClr val="000000"/>
+                </a:solidFill>
+                <a:latin typeface="Aptos Display"/>
+                <a:ea typeface="Aptos Display"/>
+                <a:cs typeface="Aptos Display"/>
+              </a:rPr>
               <a:t>The behavior node makes every driving decision</a:t>
             </a:r>
           </a:p>
@@ -4474,7 +5127,7 @@
 </p:sld>
 </file>
 
-<file path=ppt/slides/slide11.xml><?xml version="1.0" encoding="utf-8"?>
+<file path=ppt/slides/slide12.xml><?xml version="1.0" encoding="utf-8"?>
 <p:sld xmlns:a="http://schemas.openxmlformats.org/drawingml/2006/main" xmlns:p="http://schemas.openxmlformats.org/presentationml/2006/main" xmlns:r="http://schemas.openxmlformats.org/officeDocument/2006/relationships">
   <p:cSld>
     <p:spTree>
@@ -4646,7 +5299,7 @@
 </p:sld>
 </file>
 
-<file path=ppt/slides/slide12.xml><?xml version="1.0" encoding="utf-8"?>
+<file path=ppt/slides/slide13.xml><?xml version="1.0" encoding="utf-8"?>
 <p:sld xmlns:a="http://schemas.openxmlformats.org/drawingml/2006/main" xmlns:p="http://schemas.openxmlformats.org/presentationml/2006/main" xmlns:r="http://schemas.openxmlformats.org/officeDocument/2006/relationships">
   <p:cSld>
     <p:spTree>
@@ -4694,7 +5347,7 @@
 </p:sld>
 </file>
 
-<file path=ppt/slides/slide13.xml><?xml version="1.0" encoding="utf-8"?>
+<file path=ppt/slides/slide14.xml><?xml version="1.0" encoding="utf-8"?>
 <p:sld xmlns:a="http://schemas.openxmlformats.org/drawingml/2006/main" xmlns:p="http://schemas.openxmlformats.org/presentationml/2006/main" xmlns:r="http://schemas.openxmlformats.org/officeDocument/2006/relationships">
   <p:cSld>
     <p:spTree>
@@ -13300,6 +13953,48 @@
         <p:nvPr/>
       </p:nvGrpSpPr>
       <p:grpSpPr/>
+      <p:pic>
+        <p:nvPicPr>
+          <p:cNvPr id="2" name="Picture 1" descr="1.jpg"/>
+          <p:cNvPicPr>
+            <a:picLocks noChangeAspect="1"/>
+          </p:cNvPicPr>
+          <p:nvPr/>
+        </p:nvPicPr>
+        <p:blipFill>
+          <a:blip r:embed="rId2"/>
+          <a:stretch>
+            <a:fillRect/>
+          </a:stretch>
+        </p:blipFill>
+        <p:spPr>
+          <a:xfrm>
+            <a:off x="943483" y="0"/>
+            <a:ext cx="10305033" cy="6858000"/>
+          </a:xfrm>
+          <a:prstGeom prst="rect">
+            <a:avLst/>
+          </a:prstGeom>
+        </p:spPr>
+      </p:pic>
+    </p:spTree>
+  </p:cSld>
+  <p:clrMapOvr>
+    <a:masterClrMapping/>
+  </p:clrMapOvr>
+</p:sld>
+</file>
+
+<file path=ppt/slides/slide8.xml><?xml version="1.0" encoding="utf-8"?>
+<p:sld xmlns:a="http://schemas.openxmlformats.org/drawingml/2006/main" xmlns:p="http://schemas.openxmlformats.org/presentationml/2006/main" xmlns:r="http://schemas.openxmlformats.org/officeDocument/2006/relationships">
+  <p:cSld>
+    <p:spTree>
+      <p:nvGrpSpPr>
+        <p:cNvPr id="1" name=""/>
+        <p:cNvGrpSpPr/>
+        <p:nvPr/>
+      </p:nvGrpSpPr>
+      <p:grpSpPr/>
       <p:sp useBgFill="1">
         <p:nvSpPr>
           <p:cNvPr id="12" name="Rectangle 11">
@@ -13861,7 +14556,7 @@
 </p:sld>
 </file>
 
-<file path=ppt/slides/slide8.xml><?xml version="1.0" encoding="utf-8"?>
+<file path=ppt/slides/slide9.xml><?xml version="1.0" encoding="utf-8"?>
 <p:sld xmlns:a="http://schemas.openxmlformats.org/drawingml/2006/main" xmlns:p="http://schemas.openxmlformats.org/presentationml/2006/main" xmlns:r="http://schemas.openxmlformats.org/officeDocument/2006/relationships">
   <p:cSld>
     <p:spTree>
@@ -13996,658 +14691,6 @@
             <a:r>
               <a:rPr dirty="0"/>
               <a:t> hours.</a:t>
-            </a:r>
-          </a:p>
-        </p:txBody>
-      </p:sp>
-    </p:spTree>
-  </p:cSld>
-  <p:clrMapOvr>
-    <a:masterClrMapping/>
-  </p:clrMapOvr>
-</p:sld>
-</file>
-
-<file path=ppt/slides/slide9.xml><?xml version="1.0" encoding="utf-8"?>
-<p:sld xmlns:a="http://schemas.openxmlformats.org/drawingml/2006/main" xmlns:p="http://schemas.openxmlformats.org/presentationml/2006/main" xmlns:r="http://schemas.openxmlformats.org/officeDocument/2006/relationships">
-  <p:cSld>
-    <p:spTree>
-      <p:nvGrpSpPr>
-        <p:cNvPr id="1" name=""/>
-        <p:cNvGrpSpPr/>
-        <p:nvPr/>
-      </p:nvGrpSpPr>
-      <p:grpSpPr/>
-      <p:sp>
-        <p:nvSpPr>
-          <p:cNvPr id="2" name="Title"/>
-          <p:cNvSpPr>
-            <a:spLocks noGrp="1"/>
-          </p:cNvSpPr>
-          <p:nvPr>
-            <p:ph type="title"/>
-          </p:nvPr>
-        </p:nvSpPr>
-        <p:spPr>
-          <a:xfrm>
-            <a:off x="768096" y="365760"/>
-            <a:ext cx="10789920" cy="658368"/>
-          </a:xfrm>
-        </p:spPr>
-        <p:txBody>
-          <a:bodyPr lIns="0" tIns="0" rIns="0" bIns="0" anchor="b">
-            <a:normAutofit/>
-          </a:bodyPr>
-          <a:lstStyle/>
-          <a:p>
-            <a:pPr algn="l"/>
-            <a:r>
-              <a:rPr lang="en-US" sz="3500" b="0" dirty="0">
-                <a:solidFill>
-                  <a:srgbClr val="000000"/>
-                </a:solidFill>
-                <a:latin typeface="Aptos Display"/>
-                <a:ea typeface="Aptos Display"/>
-                <a:cs typeface="Aptos Display"/>
-              </a:rPr>
-              <a:t>ROS 2 could split our pipeline into eight nodes</a:t>
-            </a:r>
-          </a:p>
-        </p:txBody>
-      </p:sp>
-      <p:sp>
-        <p:nvSpPr>
-          <p:cNvPr id="3" name="Subtitle"/>
-          <p:cNvSpPr txBox="1"/>
-          <p:nvPr/>
-        </p:nvSpPr>
-        <p:spPr>
-          <a:xfrm>
-            <a:off x="786384" y="1024128"/>
-            <a:ext cx="10607040" cy="365760"/>
-          </a:xfrm>
-          <a:prstGeom prst="rect">
-            <a:avLst/>
-          </a:prstGeom>
-          <a:noFill/>
-        </p:spPr>
-        <p:txBody>
-          <a:bodyPr wrap="square" lIns="0" tIns="0" rIns="0" bIns="0" anchor="t">
-            <a:noAutofit/>
-          </a:bodyPr>
-          <a:lstStyle/>
-          <a:p>
-            <a:pPr marL="0" indent="0" algn="l">
-              <a:spcBef>
-                <a:spcPts val="0"/>
-              </a:spcBef>
-              <a:buNone/>
-            </a:pPr>
-            <a:r>
-              <a:rPr lang="en-US" sz="1500" b="1" dirty="0">
-                <a:solidFill>
-                  <a:srgbClr val="000000"/>
-                </a:solidFill>
-                <a:latin typeface="Aptos"/>
-                <a:ea typeface="Aptos"/>
-                <a:cs typeface="Aptos"/>
-              </a:rPr>
-              <a:t>Preliminary node structure for the car; each node does one job</a:t>
-            </a:r>
-          </a:p>
-        </p:txBody>
-      </p:sp>
-      <p:sp>
-        <p:nvSpPr>
-          <p:cNvPr id="4" name="Nodes"/>
-          <p:cNvSpPr txBox="1"/>
-          <p:nvPr/>
-        </p:nvSpPr>
-        <p:spPr>
-          <a:xfrm>
-            <a:off x="786384" y="1719072"/>
-            <a:ext cx="6309360" cy="384048"/>
-          </a:xfrm>
-          <a:prstGeom prst="rect">
-            <a:avLst/>
-          </a:prstGeom>
-          <a:noFill/>
-        </p:spPr>
-        <p:txBody>
-          <a:bodyPr wrap="square" lIns="0" tIns="0" rIns="0" bIns="0" anchor="t">
-            <a:noAutofit/>
-          </a:bodyPr>
-          <a:lstStyle/>
-          <a:p>
-            <a:pPr marL="0" indent="0" algn="l">
-              <a:spcBef>
-                <a:spcPts val="0"/>
-              </a:spcBef>
-              <a:buNone/>
-            </a:pPr>
-            <a:r>
-              <a:rPr lang="en-US" sz="1950" b="1" dirty="0">
-                <a:solidFill>
-                  <a:srgbClr val="30669D"/>
-                </a:solidFill>
-                <a:latin typeface="Aptos"/>
-                <a:ea typeface="Aptos"/>
-                <a:cs typeface="Aptos"/>
-              </a:rPr>
-              <a:t>Nodes</a:t>
-            </a:r>
-          </a:p>
-        </p:txBody>
-      </p:sp>
-      <p:sp>
-        <p:nvSpPr>
-          <p:cNvPr id="5" name="Node list"/>
-          <p:cNvSpPr txBox="1"/>
-          <p:nvPr/>
-        </p:nvSpPr>
-        <p:spPr>
-          <a:xfrm>
-            <a:off x="786384" y="2240280"/>
-            <a:ext cx="6309360" cy="4023360"/>
-          </a:xfrm>
-          <a:prstGeom prst="rect">
-            <a:avLst/>
-          </a:prstGeom>
-          <a:noFill/>
-        </p:spPr>
-        <p:txBody>
-          <a:bodyPr wrap="square" lIns="0" tIns="0" rIns="0" bIns="0" anchor="t">
-            <a:noAutofit/>
-          </a:bodyPr>
-          <a:lstStyle/>
-          <a:p>
-            <a:pPr marL="228600" indent="-228600" algn="l">
-              <a:spcBef>
-                <a:spcPts val="0"/>
-              </a:spcBef>
-              <a:buClr>
-                <a:srgbClr val="30669D"/>
-              </a:buClr>
-              <a:buFont typeface="Arial"/>
-              <a:buChar char="•"/>
-            </a:pPr>
-            <a:r>
-              <a:rPr lang="en-US" sz="1600" b="1" dirty="0">
-                <a:solidFill>
-                  <a:srgbClr val="000000"/>
-                </a:solidFill>
-                <a:latin typeface="Aptos"/>
-                <a:ea typeface="Aptos"/>
-                <a:cs typeface="Aptos"/>
-              </a:rPr>
-              <a:t>Camera: </a:t>
-            </a:r>
-            <a:r>
-              <a:rPr lang="en-US" sz="1600" b="0" dirty="0">
-                <a:solidFill>
-                  <a:srgbClr val="000000"/>
-                </a:solidFill>
-                <a:latin typeface="Aptos"/>
-                <a:ea typeface="Aptos"/>
-                <a:cs typeface="Aptos"/>
-              </a:rPr>
-              <a:t>streams video from the Pi Camera Module 3</a:t>
-            </a:r>
-          </a:p>
-          <a:p>
-            <a:pPr marL="228600" indent="-228600" algn="l">
-              <a:spcBef>
-                <a:spcPts val="700"/>
-              </a:spcBef>
-              <a:buClr>
-                <a:srgbClr val="30669D"/>
-              </a:buClr>
-              <a:buFont typeface="Arial"/>
-              <a:buChar char="•"/>
-            </a:pPr>
-            <a:r>
-              <a:rPr lang="en-US" sz="1600" b="1" dirty="0">
-                <a:solidFill>
-                  <a:srgbClr val="000000"/>
-                </a:solidFill>
-                <a:latin typeface="Aptos"/>
-                <a:ea typeface="Aptos"/>
-                <a:cs typeface="Aptos"/>
-              </a:rPr>
-              <a:t>Sign detector: </a:t>
-            </a:r>
-            <a:r>
-              <a:rPr lang="en-US" sz="1600" b="0" dirty="0">
-                <a:solidFill>
-                  <a:srgbClr val="000000"/>
-                </a:solidFill>
-                <a:latin typeface="Aptos"/>
-                <a:ea typeface="Aptos"/>
-                <a:cs typeface="Aptos"/>
-              </a:rPr>
-              <a:t>runs the vision model and reports each sign’s type, confidence and position</a:t>
-            </a:r>
-          </a:p>
-          <a:p>
-            <a:pPr marL="228600" indent="-228600" algn="l">
-              <a:spcBef>
-                <a:spcPts val="700"/>
-              </a:spcBef>
-              <a:buClr>
-                <a:srgbClr val="30669D"/>
-              </a:buClr>
-              <a:buFont typeface="Arial"/>
-              <a:buChar char="•"/>
-            </a:pPr>
-            <a:r>
-              <a:rPr lang="en-US" sz="1600" b="1" dirty="0">
-                <a:solidFill>
-                  <a:srgbClr val="000000"/>
-                </a:solidFill>
-                <a:latin typeface="Aptos"/>
-                <a:ea typeface="Aptos"/>
-                <a:cs typeface="Aptos"/>
-              </a:rPr>
-              <a:t>Line sensor: </a:t>
-            </a:r>
-            <a:r>
-              <a:rPr lang="en-US" sz="1600" b="0" dirty="0">
-                <a:solidFill>
-                  <a:srgbClr val="000000"/>
-                </a:solidFill>
-                <a:latin typeface="Aptos"/>
-                <a:ea typeface="Aptos"/>
-                <a:cs typeface="Aptos"/>
-              </a:rPr>
-              <a:t>tracks the lane lines with TCRT5000 IR sensors</a:t>
-            </a:r>
-          </a:p>
-          <a:p>
-            <a:pPr marL="228600" indent="-228600" algn="l">
-              <a:spcBef>
-                <a:spcPts val="700"/>
-              </a:spcBef>
-              <a:buClr>
-                <a:srgbClr val="30669D"/>
-              </a:buClr>
-              <a:buFont typeface="Arial"/>
-              <a:buChar char="•"/>
-            </a:pPr>
-            <a:r>
-              <a:rPr lang="en-US" sz="1600" b="1" dirty="0">
-                <a:solidFill>
-                  <a:srgbClr val="000000"/>
-                </a:solidFill>
-                <a:latin typeface="Aptos"/>
-                <a:ea typeface="Aptos"/>
-                <a:cs typeface="Aptos"/>
-              </a:rPr>
-              <a:t>IMU: </a:t>
-            </a:r>
-            <a:r>
-              <a:rPr lang="en-US" sz="1600" b="0" dirty="0">
-                <a:solidFill>
-                  <a:srgbClr val="000000"/>
-                </a:solidFill>
-                <a:latin typeface="Aptos"/>
-                <a:ea typeface="Aptos"/>
-                <a:cs typeface="Aptos"/>
-              </a:rPr>
-              <a:t>reports turning and motion; detects if the car is stuck</a:t>
-            </a:r>
-          </a:p>
-          <a:p>
-            <a:pPr marL="228600" indent="-228600" algn="l">
-              <a:spcBef>
-                <a:spcPts val="700"/>
-              </a:spcBef>
-              <a:buClr>
-                <a:srgbClr val="30669D"/>
-              </a:buClr>
-              <a:buFont typeface="Arial"/>
-              <a:buChar char="•"/>
-            </a:pPr>
-            <a:r>
-              <a:rPr lang="en-US" sz="1600" b="1" dirty="0">
-                <a:solidFill>
-                  <a:srgbClr val="000000"/>
-                </a:solidFill>
-                <a:latin typeface="Aptos"/>
-                <a:ea typeface="Aptos"/>
-                <a:cs typeface="Aptos"/>
-              </a:rPr>
-              <a:t>Behavior: </a:t>
-            </a:r>
-            <a:r>
-              <a:rPr lang="en-US" sz="1600" b="0" dirty="0">
-                <a:solidFill>
-                  <a:srgbClr val="000000"/>
-                </a:solidFill>
-                <a:latin typeface="Aptos"/>
-                <a:ea typeface="Aptos"/>
-                <a:cs typeface="Aptos"/>
-              </a:rPr>
-              <a:t>a state machine that turns signs, lane position and IMU data into driving decisions</a:t>
-            </a:r>
-          </a:p>
-          <a:p>
-            <a:pPr marL="228600" indent="-228600" algn="l">
-              <a:spcBef>
-                <a:spcPts val="700"/>
-              </a:spcBef>
-              <a:buClr>
-                <a:srgbClr val="30669D"/>
-              </a:buClr>
-              <a:buFont typeface="Arial"/>
-              <a:buChar char="•"/>
-            </a:pPr>
-            <a:r>
-              <a:rPr lang="en-US" sz="1600" b="1" dirty="0">
-                <a:solidFill>
-                  <a:srgbClr val="000000"/>
-                </a:solidFill>
-                <a:latin typeface="Aptos"/>
-                <a:ea typeface="Aptos"/>
-                <a:cs typeface="Aptos"/>
-              </a:rPr>
-              <a:t>Motor driver: </a:t>
-            </a:r>
-            <a:r>
-              <a:rPr lang="en-US" sz="1600" b="0" dirty="0">
-                <a:solidFill>
-                  <a:srgbClr val="000000"/>
-                </a:solidFill>
-                <a:latin typeface="Aptos"/>
-                <a:ea typeface="Aptos"/>
-                <a:cs typeface="Aptos"/>
-              </a:rPr>
-              <a:t>drives the wheels through the Waveshare HAT and stops if commands stop arriving</a:t>
-            </a:r>
-          </a:p>
-          <a:p>
-            <a:pPr marL="228600" indent="-228600" algn="l">
-              <a:spcBef>
-                <a:spcPts val="700"/>
-              </a:spcBef>
-              <a:buClr>
-                <a:srgbClr val="30669D"/>
-              </a:buClr>
-              <a:buFont typeface="Arial"/>
-              <a:buChar char="•"/>
-            </a:pPr>
-            <a:r>
-              <a:rPr lang="en-US" sz="1600" b="1" dirty="0">
-                <a:solidFill>
-                  <a:srgbClr val="000000"/>
-                </a:solidFill>
-                <a:latin typeface="Aptos"/>
-                <a:ea typeface="Aptos"/>
-                <a:cs typeface="Aptos"/>
-              </a:rPr>
-              <a:t>LCD: </a:t>
-            </a:r>
-            <a:r>
-              <a:rPr lang="en-US" sz="1600" b="0" dirty="0">
-                <a:solidFill>
-                  <a:srgbClr val="000000"/>
-                </a:solidFill>
-                <a:latin typeface="Aptos"/>
-                <a:ea typeface="Aptos"/>
-                <a:cs typeface="Aptos"/>
-              </a:rPr>
-              <a:t>shows the car’s state and the last sign detected</a:t>
-            </a:r>
-          </a:p>
-          <a:p>
-            <a:pPr marL="228600" indent="-228600" algn="l">
-              <a:spcBef>
-                <a:spcPts val="700"/>
-              </a:spcBef>
-              <a:buClr>
-                <a:srgbClr val="30669D"/>
-              </a:buClr>
-              <a:buFont typeface="Arial"/>
-              <a:buChar char="•"/>
-            </a:pPr>
-            <a:r>
-              <a:rPr lang="en-US" sz="1600" b="1" dirty="0">
-                <a:solidFill>
-                  <a:srgbClr val="000000"/>
-                </a:solidFill>
-                <a:latin typeface="Aptos"/>
-                <a:ea typeface="Aptos"/>
-                <a:cs typeface="Aptos"/>
-              </a:rPr>
-              <a:t>Teleop: </a:t>
-            </a:r>
-            <a:r>
-              <a:rPr lang="en-US" sz="1600" b="0" dirty="0">
-                <a:solidFill>
-                  <a:srgbClr val="000000"/>
-                </a:solidFill>
-                <a:latin typeface="Aptos"/>
-                <a:ea typeface="Aptos"/>
-                <a:cs typeface="Aptos"/>
-              </a:rPr>
-              <a:t>lets a person take over and drive manually</a:t>
-            </a:r>
-          </a:p>
-        </p:txBody>
-      </p:sp>
-      <p:sp>
-        <p:nvSpPr>
-          <p:cNvPr id="6" name="Why ROS 2"/>
-          <p:cNvSpPr txBox="1"/>
-          <p:nvPr/>
-        </p:nvSpPr>
-        <p:spPr>
-          <a:xfrm>
-            <a:off x="7635240" y="1719072"/>
-            <a:ext cx="3794760" cy="384048"/>
-          </a:xfrm>
-          <a:prstGeom prst="rect">
-            <a:avLst/>
-          </a:prstGeom>
-          <a:noFill/>
-        </p:spPr>
-        <p:txBody>
-          <a:bodyPr wrap="square" lIns="0" tIns="0" rIns="0" bIns="0" anchor="t">
-            <a:noAutofit/>
-          </a:bodyPr>
-          <a:lstStyle/>
-          <a:p>
-            <a:pPr marL="0" indent="0" algn="l">
-              <a:spcBef>
-                <a:spcPts val="0"/>
-              </a:spcBef>
-              <a:buNone/>
-            </a:pPr>
-            <a:r>
-              <a:rPr lang="en-US" sz="1950" b="1" dirty="0">
-                <a:solidFill>
-                  <a:srgbClr val="30669D"/>
-                </a:solidFill>
-                <a:latin typeface="Aptos"/>
-                <a:ea typeface="Aptos"/>
-                <a:cs typeface="Aptos"/>
-              </a:rPr>
-              <a:t>Why ROS 2</a:t>
-            </a:r>
-          </a:p>
-        </p:txBody>
-      </p:sp>
-      <p:sp>
-        <p:nvSpPr>
-          <p:cNvPr id="7" name="Why ROS 2 list"/>
-          <p:cNvSpPr txBox="1"/>
-          <p:nvPr/>
-        </p:nvSpPr>
-        <p:spPr>
-          <a:xfrm>
-            <a:off x="7635240" y="2240280"/>
-            <a:ext cx="3794760" cy="2103120"/>
-          </a:xfrm>
-          <a:prstGeom prst="rect">
-            <a:avLst/>
-          </a:prstGeom>
-          <a:noFill/>
-        </p:spPr>
-        <p:txBody>
-          <a:bodyPr wrap="square" lIns="0" tIns="0" rIns="0" bIns="0" anchor="t">
-            <a:noAutofit/>
-          </a:bodyPr>
-          <a:lstStyle/>
-          <a:p>
-            <a:pPr marL="228600" indent="-228600" algn="l">
-              <a:spcBef>
-                <a:spcPts val="0"/>
-              </a:spcBef>
-              <a:buClr>
-                <a:srgbClr val="30669D"/>
-              </a:buClr>
-              <a:buFont typeface="Arial"/>
-              <a:buChar char="•"/>
-            </a:pPr>
-            <a:r>
-              <a:rPr lang="en-US" sz="1600" b="0" dirty="0">
-                <a:solidFill>
-                  <a:srgbClr val="000000"/>
-                </a:solidFill>
-                <a:latin typeface="Aptos"/>
-                <a:ea typeface="Aptos"/>
-                <a:cs typeface="Aptos"/>
-              </a:rPr>
-              <a:t>Each teammate can own a node without touching the others</a:t>
-            </a:r>
-          </a:p>
-          <a:p>
-            <a:pPr marL="228600" indent="-228600" algn="l">
-              <a:spcBef>
-                <a:spcPts val="900"/>
-              </a:spcBef>
-              <a:buClr>
-                <a:srgbClr val="30669D"/>
-              </a:buClr>
-              <a:buFont typeface="Arial"/>
-              <a:buChar char="•"/>
-            </a:pPr>
-            <a:r>
-              <a:rPr lang="en-US" sz="1600" b="0" dirty="0">
-                <a:solidFill>
-                  <a:srgbClr val="000000"/>
-                </a:solidFill>
-                <a:latin typeface="Aptos"/>
-                <a:ea typeface="Aptos"/>
-                <a:cs typeface="Aptos"/>
-              </a:rPr>
-              <a:t>Recorded drives can be replayed to test without the car</a:t>
-            </a:r>
-          </a:p>
-          <a:p>
-            <a:pPr marL="228600" indent="-228600" algn="l">
-              <a:spcBef>
-                <a:spcPts val="900"/>
-              </a:spcBef>
-              <a:buClr>
-                <a:srgbClr val="30669D"/>
-              </a:buClr>
-              <a:buFont typeface="Arial"/>
-              <a:buChar char="•"/>
-            </a:pPr>
-            <a:r>
-              <a:rPr lang="en-US" sz="1600" b="0" dirty="0">
-                <a:solidFill>
-                  <a:srgbClr val="000000"/>
-                </a:solidFill>
-                <a:latin typeface="Aptos"/>
-                <a:ea typeface="Aptos"/>
-                <a:cs typeface="Aptos"/>
-              </a:rPr>
-              <a:t>Laptops can watch the camera feed and topics live</a:t>
-            </a:r>
-          </a:p>
-        </p:txBody>
-      </p:sp>
-      <p:sp>
-        <p:nvSpPr>
-          <p:cNvPr id="8" name="Trade-off"/>
-          <p:cNvSpPr txBox="1"/>
-          <p:nvPr/>
-        </p:nvSpPr>
-        <p:spPr>
-          <a:xfrm>
-            <a:off x="7635240" y="4434840"/>
-            <a:ext cx="3794760" cy="384048"/>
-          </a:xfrm>
-          <a:prstGeom prst="rect">
-            <a:avLst/>
-          </a:prstGeom>
-          <a:noFill/>
-        </p:spPr>
-        <p:txBody>
-          <a:bodyPr wrap="square" lIns="0" tIns="0" rIns="0" bIns="0" anchor="t">
-            <a:noAutofit/>
-          </a:bodyPr>
-          <a:lstStyle/>
-          <a:p>
-            <a:pPr marL="0" indent="0" algn="l">
-              <a:spcBef>
-                <a:spcPts val="0"/>
-              </a:spcBef>
-              <a:buNone/>
-            </a:pPr>
-            <a:r>
-              <a:rPr lang="en-US" sz="1950" b="1" dirty="0">
-                <a:solidFill>
-                  <a:srgbClr val="30669D"/>
-                </a:solidFill>
-                <a:latin typeface="Aptos"/>
-                <a:ea typeface="Aptos"/>
-                <a:cs typeface="Aptos"/>
-              </a:rPr>
-              <a:t>Trade-off</a:t>
-            </a:r>
-          </a:p>
-        </p:txBody>
-      </p:sp>
-      <p:sp>
-        <p:nvSpPr>
-          <p:cNvPr id="9" name="Trade-off text"/>
-          <p:cNvSpPr txBox="1"/>
-          <p:nvPr/>
-        </p:nvSpPr>
-        <p:spPr>
-          <a:xfrm>
-            <a:off x="7635240" y="4956048"/>
-            <a:ext cx="3794760" cy="1280160"/>
-          </a:xfrm>
-          <a:prstGeom prst="rect">
-            <a:avLst/>
-          </a:prstGeom>
-          <a:noFill/>
-        </p:spPr>
-        <p:txBody>
-          <a:bodyPr wrap="square" lIns="0" tIns="0" rIns="0" bIns="0" anchor="t">
-            <a:noAutofit/>
-          </a:bodyPr>
-          <a:lstStyle/>
-          <a:p>
-            <a:pPr marL="0" indent="0" algn="l">
-              <a:spcBef>
-                <a:spcPts val="0"/>
-              </a:spcBef>
-              <a:buNone/>
-            </a:pPr>
-            <a:r>
-              <a:rPr lang="en-US" sz="1600" b="0" dirty="0">
-                <a:solidFill>
-                  <a:srgbClr val="000000"/>
-                </a:solidFill>
-                <a:latin typeface="Aptos"/>
-                <a:ea typeface="Aptos"/>
-                <a:cs typeface="Aptos"/>
-              </a:rPr>
-              <a:t>More upfront setup than a single script, including a custom Docker build for the CM5 camera</a:t>
             </a:r>
           </a:p>
         </p:txBody>

</xml_diff>